<commit_message>
began work on our data frame configuration and simulating CRC
</commit_message>
<xml_diff>
--- a/HOOTER_ESP32/lib/Data_Encoder/AA_block_diagram.pptx
+++ b/HOOTER_ESP32/lib/Data_Encoder/AA_block_diagram.pptx
@@ -5,8 +5,8 @@
     <p:sldMasterId id="2147483648" r:id="rId1"/>
   </p:sldMasterIdLst>
   <p:sldIdLst>
-    <p:sldId id="257" r:id="rId2"/>
-    <p:sldId id="258" r:id="rId3"/>
+    <p:sldId id="258" r:id="rId2"/>
+    <p:sldId id="259" r:id="rId3"/>
   </p:sldIdLst>
   <p:sldSz cx="12192000" cy="6858000"/>
   <p:notesSz cx="6858000" cy="9144000"/>
@@ -105,13 +105,18 @@
       </a:defRPr>
     </a:lvl9pPr>
   </p:defaultTextStyle>
+  <p:extLst>
+    <p:ext uri="{EFAFB233-063F-42B5-8137-9DF3F51BA10A}">
+      <p15:sldGuideLst xmlns:p15="http://schemas.microsoft.com/office/powerpoint/2012/main"/>
+    </p:ext>
+  </p:extLst>
 </p:presentation>
 </file>
 
 <file path=ppt/revisionInfo.xml><?xml version="1.0" encoding="utf-8"?>
 <p1510:revInfo xmlns:a="http://schemas.openxmlformats.org/drawingml/2006/main" xmlns:r="http://schemas.openxmlformats.org/officeDocument/2006/relationships" xmlns:p1510="http://schemas.microsoft.com/office/powerpoint/2015/10/main">
   <p1510:revLst>
-    <p1510:client id="{3F768CBD-1D54-4FD8-9535-A6E692DC0B64}" v="12" dt="2026-10-29T23:07:33.762"/>
+    <p1510:client id="{3F768CBD-1D54-4FD8-9535-A6E692DC0B64}" v="18" dt="2026-10-30T03:42:58.573"/>
   </p1510:revLst>
 </p1510:revInfo>
 </file>
@@ -120,8 +125,8 @@
 <pc:chgInfo xmlns:a="http://schemas.openxmlformats.org/drawingml/2006/main" xmlns:r="http://schemas.openxmlformats.org/officeDocument/2006/relationships" xmlns:ac="http://schemas.microsoft.com/office/drawing/2013/main/command" xmlns:pc="http://schemas.microsoft.com/office/powerpoint/2013/main/command">
   <pc:docChgLst>
     <pc:chgData name="Salvatore Tanelli" userId="9ff86775-5430-4d45-8a3a-c03297894c78" providerId="ADAL" clId="{D8E9A0CB-B4A6-4058-81D9-150C5E892AD5}"/>
-    <pc:docChg chg="addSld modSld">
-      <pc:chgData name="Salvatore Tanelli" userId="9ff86775-5430-4d45-8a3a-c03297894c78" providerId="ADAL" clId="{D8E9A0CB-B4A6-4058-81D9-150C5E892AD5}" dt="2026-10-29T20:33:54.797" v="11"/>
+    <pc:docChg chg="undo custSel addSld delSld modSld">
+      <pc:chgData name="Salvatore Tanelli" userId="9ff86775-5430-4d45-8a3a-c03297894c78" providerId="ADAL" clId="{D8E9A0CB-B4A6-4058-81D9-150C5E892AD5}" dt="2026-10-30T03:45:58.660" v="103" actId="2711"/>
       <pc:docMkLst>
         <pc:docMk/>
       </pc:docMkLst>
@@ -140,8 +145,8 @@
           </ac:spMkLst>
         </pc:spChg>
       </pc:sldChg>
-      <pc:sldChg chg="addSp delSp modSp">
-        <pc:chgData name="Salvatore Tanelli" userId="9ff86775-5430-4d45-8a3a-c03297894c78" providerId="ADAL" clId="{D8E9A0CB-B4A6-4058-81D9-150C5E892AD5}" dt="2026-10-29T17:25:36.927" v="4"/>
+      <pc:sldChg chg="addSp delSp modSp del">
+        <pc:chgData name="Salvatore Tanelli" userId="9ff86775-5430-4d45-8a3a-c03297894c78" providerId="ADAL" clId="{D8E9A0CB-B4A6-4058-81D9-150C5E892AD5}" dt="2026-10-30T03:08:21.822" v="12" actId="47"/>
         <pc:sldMkLst>
           <pc:docMk/>
           <pc:sldMk cId="2689763080" sldId="257"/>
@@ -201,6 +206,133 @@
             <ac:picMk id="49" creationId="{27C25A5A-ED6B-261A-A42D-F34291E0DAF9}"/>
           </ac:picMkLst>
         </pc:picChg>
+      </pc:sldChg>
+      <pc:sldChg chg="addSp delSp modSp add mod">
+        <pc:chgData name="Salvatore Tanelli" userId="9ff86775-5430-4d45-8a3a-c03297894c78" providerId="ADAL" clId="{D8E9A0CB-B4A6-4058-81D9-150C5E892AD5}" dt="2026-10-30T03:45:58.660" v="103" actId="2711"/>
+        <pc:sldMkLst>
+          <pc:docMk/>
+          <pc:sldMk cId="3549183859" sldId="259"/>
+        </pc:sldMkLst>
+        <pc:spChg chg="del">
+          <ac:chgData name="Salvatore Tanelli" userId="9ff86775-5430-4d45-8a3a-c03297894c78" providerId="ADAL" clId="{D8E9A0CB-B4A6-4058-81D9-150C5E892AD5}" dt="2026-10-30T03:42:20.460" v="28" actId="478"/>
+          <ac:spMkLst>
+            <pc:docMk/>
+            <pc:sldMk cId="3549183859" sldId="259"/>
+            <ac:spMk id="4" creationId="{A9C47EA8-9C4C-E03E-91A3-9A04AD96311E}"/>
+          </ac:spMkLst>
+        </pc:spChg>
+        <pc:spChg chg="del">
+          <ac:chgData name="Salvatore Tanelli" userId="9ff86775-5430-4d45-8a3a-c03297894c78" providerId="ADAL" clId="{D8E9A0CB-B4A6-4058-81D9-150C5E892AD5}" dt="2026-10-30T03:08:31.128" v="15" actId="478"/>
+          <ac:spMkLst>
+            <pc:docMk/>
+            <pc:sldMk cId="3549183859" sldId="259"/>
+            <ac:spMk id="8" creationId="{3D359F17-9589-7338-46EF-2CA56C18A585}"/>
+          </ac:spMkLst>
+        </pc:spChg>
+        <pc:spChg chg="add del">
+          <ac:chgData name="Salvatore Tanelli" userId="9ff86775-5430-4d45-8a3a-c03297894c78" providerId="ADAL" clId="{D8E9A0CB-B4A6-4058-81D9-150C5E892AD5}" dt="2026-10-30T03:35:20.305" v="24" actId="22"/>
+          <ac:spMkLst>
+            <pc:docMk/>
+            <pc:sldMk cId="3549183859" sldId="259"/>
+            <ac:spMk id="11" creationId="{7E17A8C5-2789-B212-456D-17FA702E314C}"/>
+          </ac:spMkLst>
+        </pc:spChg>
+        <pc:spChg chg="del">
+          <ac:chgData name="Salvatore Tanelli" userId="9ff86775-5430-4d45-8a3a-c03297894c78" providerId="ADAL" clId="{D8E9A0CB-B4A6-4058-81D9-150C5E892AD5}" dt="2026-10-30T03:08:31.128" v="15" actId="478"/>
+          <ac:spMkLst>
+            <pc:docMk/>
+            <pc:sldMk cId="3549183859" sldId="259"/>
+            <ac:spMk id="15" creationId="{CD90EA68-C6FE-31A4-4CB8-9FD630466F27}"/>
+          </ac:spMkLst>
+        </pc:spChg>
+        <pc:spChg chg="del">
+          <ac:chgData name="Salvatore Tanelli" userId="9ff86775-5430-4d45-8a3a-c03297894c78" providerId="ADAL" clId="{D8E9A0CB-B4A6-4058-81D9-150C5E892AD5}" dt="2026-10-30T03:08:31.128" v="15" actId="478"/>
+          <ac:spMkLst>
+            <pc:docMk/>
+            <pc:sldMk cId="3549183859" sldId="259"/>
+            <ac:spMk id="17" creationId="{E92ACD57-2C6A-3787-FAB7-0068FFA767F4}"/>
+          </ac:spMkLst>
+        </pc:spChg>
+        <pc:spChg chg="del">
+          <ac:chgData name="Salvatore Tanelli" userId="9ff86775-5430-4d45-8a3a-c03297894c78" providerId="ADAL" clId="{D8E9A0CB-B4A6-4058-81D9-150C5E892AD5}" dt="2026-10-30T03:08:31.128" v="15" actId="478"/>
+          <ac:spMkLst>
+            <pc:docMk/>
+            <pc:sldMk cId="3549183859" sldId="259"/>
+            <ac:spMk id="19" creationId="{CF22F7B6-4F97-AA7D-94E6-66C3C567E12D}"/>
+          </ac:spMkLst>
+        </pc:spChg>
+        <pc:spChg chg="del">
+          <ac:chgData name="Salvatore Tanelli" userId="9ff86775-5430-4d45-8a3a-c03297894c78" providerId="ADAL" clId="{D8E9A0CB-B4A6-4058-81D9-150C5E892AD5}" dt="2026-10-30T03:08:27.913" v="14" actId="478"/>
+          <ac:spMkLst>
+            <pc:docMk/>
+            <pc:sldMk cId="3549183859" sldId="259"/>
+            <ac:spMk id="21" creationId="{43DD3EFB-2152-8A90-B081-726813E55669}"/>
+          </ac:spMkLst>
+        </pc:spChg>
+        <pc:spChg chg="del">
+          <ac:chgData name="Salvatore Tanelli" userId="9ff86775-5430-4d45-8a3a-c03297894c78" providerId="ADAL" clId="{D8E9A0CB-B4A6-4058-81D9-150C5E892AD5}" dt="2026-10-30T03:08:31.128" v="15" actId="478"/>
+          <ac:spMkLst>
+            <pc:docMk/>
+            <pc:sldMk cId="3549183859" sldId="259"/>
+            <ac:spMk id="58" creationId="{41AB7CE9-0B71-5216-C2BF-7ABF5A417D00}"/>
+          </ac:spMkLst>
+        </pc:spChg>
+        <pc:spChg chg="del">
+          <ac:chgData name="Salvatore Tanelli" userId="9ff86775-5430-4d45-8a3a-c03297894c78" providerId="ADAL" clId="{D8E9A0CB-B4A6-4058-81D9-150C5E892AD5}" dt="2026-10-30T03:08:31.128" v="15" actId="478"/>
+          <ac:spMkLst>
+            <pc:docMk/>
+            <pc:sldMk cId="3549183859" sldId="259"/>
+            <ac:spMk id="64" creationId="{BCC22949-E087-66BB-0B9C-14DB4E7E4FE0}"/>
+          </ac:spMkLst>
+        </pc:spChg>
+        <pc:spChg chg="del">
+          <ac:chgData name="Salvatore Tanelli" userId="9ff86775-5430-4d45-8a3a-c03297894c78" providerId="ADAL" clId="{D8E9A0CB-B4A6-4058-81D9-150C5E892AD5}" dt="2026-10-30T03:08:31.128" v="15" actId="478"/>
+          <ac:spMkLst>
+            <pc:docMk/>
+            <pc:sldMk cId="3549183859" sldId="259"/>
+            <ac:spMk id="90" creationId="{85BEB002-2227-D697-8468-70BB841DF08C}"/>
+          </ac:spMkLst>
+        </pc:spChg>
+        <pc:spChg chg="del">
+          <ac:chgData name="Salvatore Tanelli" userId="9ff86775-5430-4d45-8a3a-c03297894c78" providerId="ADAL" clId="{D8E9A0CB-B4A6-4058-81D9-150C5E892AD5}" dt="2026-10-30T03:08:31.128" v="15" actId="478"/>
+          <ac:spMkLst>
+            <pc:docMk/>
+            <pc:sldMk cId="3549183859" sldId="259"/>
+            <ac:spMk id="110" creationId="{38AB923F-BE32-A070-4473-86D001A3DCE6}"/>
+          </ac:spMkLst>
+        </pc:spChg>
+        <pc:spChg chg="del">
+          <ac:chgData name="Salvatore Tanelli" userId="9ff86775-5430-4d45-8a3a-c03297894c78" providerId="ADAL" clId="{D8E9A0CB-B4A6-4058-81D9-150C5E892AD5}" dt="2026-10-30T03:08:31.128" v="15" actId="478"/>
+          <ac:spMkLst>
+            <pc:docMk/>
+            <pc:sldMk cId="3549183859" sldId="259"/>
+            <ac:spMk id="118" creationId="{8D744C8E-5F01-5944-564B-4F31B635A2D3}"/>
+          </ac:spMkLst>
+        </pc:spChg>
+        <pc:spChg chg="del">
+          <ac:chgData name="Salvatore Tanelli" userId="9ff86775-5430-4d45-8a3a-c03297894c78" providerId="ADAL" clId="{D8E9A0CB-B4A6-4058-81D9-150C5E892AD5}" dt="2026-10-30T03:08:31.128" v="15" actId="478"/>
+          <ac:spMkLst>
+            <pc:docMk/>
+            <pc:sldMk cId="3549183859" sldId="259"/>
+            <ac:spMk id="127" creationId="{29DDD49B-8410-8C31-370C-C0B13D882AE4}"/>
+          </ac:spMkLst>
+        </pc:spChg>
+        <pc:graphicFrameChg chg="add mod modGraphic">
+          <ac:chgData name="Salvatore Tanelli" userId="9ff86775-5430-4d45-8a3a-c03297894c78" providerId="ADAL" clId="{D8E9A0CB-B4A6-4058-81D9-150C5E892AD5}" dt="2026-10-30T03:35:05.018" v="22" actId="1076"/>
+          <ac:graphicFrameMkLst>
+            <pc:docMk/>
+            <pc:sldMk cId="3549183859" sldId="259"/>
+            <ac:graphicFrameMk id="6" creationId="{3FAF5333-C13E-C54F-DA76-6198562894B1}"/>
+          </ac:graphicFrameMkLst>
+        </pc:graphicFrameChg>
+        <pc:graphicFrameChg chg="add mod modGraphic">
+          <ac:chgData name="Salvatore Tanelli" userId="9ff86775-5430-4d45-8a3a-c03297894c78" providerId="ADAL" clId="{D8E9A0CB-B4A6-4058-81D9-150C5E892AD5}" dt="2026-10-30T03:45:58.660" v="103" actId="2711"/>
+          <ac:graphicFrameMkLst>
+            <pc:docMk/>
+            <pc:sldMk cId="3549183859" sldId="259"/>
+            <ac:graphicFrameMk id="12" creationId="{D50B234F-5A5B-2CB2-DA3C-6B67A60AE135}"/>
+          </ac:graphicFrameMkLst>
+        </pc:graphicFrameChg>
       </pc:sldChg>
     </pc:docChg>
   </pc:docChgLst>
@@ -3409,865 +3541,6 @@
   <p:cSld>
     <p:spTree>
       <p:nvGrpSpPr>
-        <p:cNvPr id="1" name=""/>
-        <p:cNvGrpSpPr/>
-        <p:nvPr/>
-      </p:nvGrpSpPr>
-      <p:grpSpPr>
-        <a:xfrm>
-          <a:off x="0" y="0"/>
-          <a:ext cx="0" cy="0"/>
-          <a:chOff x="0" y="0"/>
-          <a:chExt cx="0" cy="0"/>
-        </a:xfrm>
-      </p:grpSpPr>
-      <p:sp>
-        <p:nvSpPr>
-          <p:cNvPr id="21" name="Rectangle 20">
-            <a:extLst>
-              <a:ext uri="{FF2B5EF4-FFF2-40B4-BE49-F238E27FC236}">
-                <a16:creationId xmlns:a16="http://schemas.microsoft.com/office/drawing/2014/main" id="{57E5FD72-65B3-6A7D-8A6D-28A9CA353F1F}"/>
-              </a:ext>
-            </a:extLst>
-          </p:cNvPr>
-          <p:cNvSpPr/>
-          <p:nvPr/>
-        </p:nvSpPr>
-        <p:spPr>
-          <a:xfrm>
-            <a:off x="808371" y="1097755"/>
-            <a:ext cx="10570369" cy="2859883"/>
-          </a:xfrm>
-          <a:prstGeom prst="rect">
-            <a:avLst/>
-          </a:prstGeom>
-          <a:solidFill>
-            <a:schemeClr val="accent2">
-              <a:lumMod val="20000"/>
-              <a:lumOff val="80000"/>
-            </a:schemeClr>
-          </a:solidFill>
-          <a:ln>
-            <a:solidFill>
-              <a:schemeClr val="tx1"/>
-            </a:solidFill>
-          </a:ln>
-        </p:spPr>
-        <p:style>
-          <a:lnRef idx="2">
-            <a:schemeClr val="accent6"/>
-          </a:lnRef>
-          <a:fillRef idx="1">
-            <a:schemeClr val="lt1"/>
-          </a:fillRef>
-          <a:effectRef idx="0">
-            <a:schemeClr val="accent6"/>
-          </a:effectRef>
-          <a:fontRef idx="minor">
-            <a:schemeClr val="dk1"/>
-          </a:fontRef>
-        </p:style>
-        <p:txBody>
-          <a:bodyPr rtlCol="0" anchor="t" anchorCtr="0"/>
-          <a:lstStyle/>
-          <a:p>
-            <a:r>
-              <a:rPr lang="en-US" dirty="0"/>
-              <a:t>Payload</a:t>
-            </a:r>
-          </a:p>
-        </p:txBody>
-      </p:sp>
-      <p:sp>
-        <p:nvSpPr>
-          <p:cNvPr id="2" name="Title 1">
-            <a:extLst>
-              <a:ext uri="{FF2B5EF4-FFF2-40B4-BE49-F238E27FC236}">
-                <a16:creationId xmlns:a16="http://schemas.microsoft.com/office/drawing/2014/main" id="{C48381F2-80EB-6E83-7C44-FA5B2E2D247B}"/>
-              </a:ext>
-            </a:extLst>
-          </p:cNvPr>
-          <p:cNvSpPr>
-            <a:spLocks noGrp="1"/>
-          </p:cNvSpPr>
-          <p:nvPr>
-            <p:ph type="title"/>
-          </p:nvPr>
-        </p:nvSpPr>
-        <p:spPr>
-          <a:xfrm>
-            <a:off x="838200" y="365125"/>
-            <a:ext cx="10515600" cy="589755"/>
-          </a:xfrm>
-        </p:spPr>
-        <p:txBody>
-          <a:bodyPr>
-            <a:normAutofit fontScale="90000"/>
-          </a:bodyPr>
-          <a:lstStyle/>
-          <a:p>
-            <a:pPr algn="ctr"/>
-            <a:r>
-              <a:rPr lang="en-US" dirty="0"/>
-              <a:t>General Encoding Design</a:t>
-            </a:r>
-          </a:p>
-        </p:txBody>
-      </p:sp>
-      <p:sp>
-        <p:nvSpPr>
-          <p:cNvPr id="5" name="Rectangle 4">
-            <a:extLst>
-              <a:ext uri="{FF2B5EF4-FFF2-40B4-BE49-F238E27FC236}">
-                <a16:creationId xmlns:a16="http://schemas.microsoft.com/office/drawing/2014/main" id="{D083A175-4E02-0D44-2BC2-0AF78E4FC54F}"/>
-              </a:ext>
-            </a:extLst>
-          </p:cNvPr>
-          <p:cNvSpPr/>
-          <p:nvPr/>
-        </p:nvSpPr>
-        <p:spPr>
-          <a:xfrm>
-            <a:off x="1928155" y="1474788"/>
-            <a:ext cx="8330803" cy="1606550"/>
-          </a:xfrm>
-          <a:prstGeom prst="rect">
-            <a:avLst/>
-          </a:prstGeom>
-          <a:solidFill>
-            <a:schemeClr val="accent5">
-              <a:lumMod val="20000"/>
-              <a:lumOff val="80000"/>
-            </a:schemeClr>
-          </a:solidFill>
-          <a:ln>
-            <a:solidFill>
-              <a:schemeClr val="tx1"/>
-            </a:solidFill>
-          </a:ln>
-        </p:spPr>
-        <p:style>
-          <a:lnRef idx="2">
-            <a:schemeClr val="accent6"/>
-          </a:lnRef>
-          <a:fillRef idx="1">
-            <a:schemeClr val="lt1"/>
-          </a:fillRef>
-          <a:effectRef idx="0">
-            <a:schemeClr val="accent6"/>
-          </a:effectRef>
-          <a:fontRef idx="minor">
-            <a:schemeClr val="dk1"/>
-          </a:fontRef>
-        </p:style>
-        <p:txBody>
-          <a:bodyPr rtlCol="0" anchor="t" anchorCtr="0"/>
-          <a:lstStyle/>
-          <a:p>
-            <a:r>
-              <a:rPr lang="en-US" dirty="0"/>
-              <a:t>Avionics Board</a:t>
-            </a:r>
-          </a:p>
-        </p:txBody>
-      </p:sp>
-      <p:sp>
-        <p:nvSpPr>
-          <p:cNvPr id="7" name="Rectangle 6">
-            <a:extLst>
-              <a:ext uri="{FF2B5EF4-FFF2-40B4-BE49-F238E27FC236}">
-                <a16:creationId xmlns:a16="http://schemas.microsoft.com/office/drawing/2014/main" id="{E373FF10-A6F0-CB49-F39C-EB0918AE35BA}"/>
-              </a:ext>
-            </a:extLst>
-          </p:cNvPr>
-          <p:cNvSpPr/>
-          <p:nvPr/>
-        </p:nvSpPr>
-        <p:spPr>
-          <a:xfrm>
-            <a:off x="2071421" y="1994693"/>
-            <a:ext cx="1371600" cy="914400"/>
-          </a:xfrm>
-          <a:prstGeom prst="rect">
-            <a:avLst/>
-          </a:prstGeom>
-          <a:solidFill>
-            <a:schemeClr val="accent1">
-              <a:lumMod val="20000"/>
-              <a:lumOff val="80000"/>
-            </a:schemeClr>
-          </a:solidFill>
-        </p:spPr>
-        <p:style>
-          <a:lnRef idx="2">
-            <a:schemeClr val="accent1">
-              <a:shade val="15000"/>
-            </a:schemeClr>
-          </a:lnRef>
-          <a:fillRef idx="1">
-            <a:schemeClr val="accent1"/>
-          </a:fillRef>
-          <a:effectRef idx="0">
-            <a:schemeClr val="accent1"/>
-          </a:effectRef>
-          <a:fontRef idx="minor">
-            <a:schemeClr val="lt1"/>
-          </a:fontRef>
-        </p:style>
-        <p:txBody>
-          <a:bodyPr rtlCol="0" anchor="ctr"/>
-          <a:lstStyle/>
-          <a:p>
-            <a:pPr algn="ctr"/>
-            <a:r>
-              <a:rPr lang="en-US" sz="1600" dirty="0">
-                <a:solidFill>
-                  <a:schemeClr val="tx1"/>
-                </a:solidFill>
-              </a:rPr>
-              <a:t>Data Acquisition</a:t>
-            </a:r>
-          </a:p>
-          <a:p>
-            <a:pPr algn="ctr"/>
-            <a:r>
-              <a:rPr lang="en-US" sz="1600" dirty="0">
-                <a:solidFill>
-                  <a:schemeClr val="tx1"/>
-                </a:solidFill>
-              </a:rPr>
-              <a:t>(Sensors)</a:t>
-            </a:r>
-          </a:p>
-        </p:txBody>
-      </p:sp>
-      <p:sp>
-        <p:nvSpPr>
-          <p:cNvPr id="9" name="Rectangle 8">
-            <a:extLst>
-              <a:ext uri="{FF2B5EF4-FFF2-40B4-BE49-F238E27FC236}">
-                <a16:creationId xmlns:a16="http://schemas.microsoft.com/office/drawing/2014/main" id="{BDF433C9-BDC4-96AF-0666-96DB6DC6300F}"/>
-              </a:ext>
-            </a:extLst>
-          </p:cNvPr>
-          <p:cNvSpPr/>
-          <p:nvPr/>
-        </p:nvSpPr>
-        <p:spPr>
-          <a:xfrm>
-            <a:off x="3737144" y="1994693"/>
-            <a:ext cx="1371600" cy="914400"/>
-          </a:xfrm>
-          <a:prstGeom prst="rect">
-            <a:avLst/>
-          </a:prstGeom>
-          <a:solidFill>
-            <a:schemeClr val="accent6">
-              <a:lumMod val="20000"/>
-              <a:lumOff val="80000"/>
-            </a:schemeClr>
-          </a:solidFill>
-        </p:spPr>
-        <p:style>
-          <a:lnRef idx="2">
-            <a:schemeClr val="accent1">
-              <a:shade val="15000"/>
-            </a:schemeClr>
-          </a:lnRef>
-          <a:fillRef idx="1">
-            <a:schemeClr val="accent1"/>
-          </a:fillRef>
-          <a:effectRef idx="0">
-            <a:schemeClr val="accent1"/>
-          </a:effectRef>
-          <a:fontRef idx="minor">
-            <a:schemeClr val="lt1"/>
-          </a:fontRef>
-        </p:style>
-        <p:txBody>
-          <a:bodyPr rtlCol="0" anchor="ctr"/>
-          <a:lstStyle/>
-          <a:p>
-            <a:pPr algn="ctr"/>
-            <a:r>
-              <a:rPr lang="en-US" sz="1600" dirty="0">
-                <a:solidFill>
-                  <a:schemeClr val="tx1"/>
-                </a:solidFill>
-              </a:rPr>
-              <a:t>CRC Computation</a:t>
-            </a:r>
-          </a:p>
-        </p:txBody>
-      </p:sp>
-      <p:sp>
-        <p:nvSpPr>
-          <p:cNvPr id="13" name="Rectangle 12">
-            <a:extLst>
-              <a:ext uri="{FF2B5EF4-FFF2-40B4-BE49-F238E27FC236}">
-                <a16:creationId xmlns:a16="http://schemas.microsoft.com/office/drawing/2014/main" id="{ABC128CE-36AE-9364-00FC-F13AD479A419}"/>
-              </a:ext>
-            </a:extLst>
-          </p:cNvPr>
-          <p:cNvSpPr/>
-          <p:nvPr/>
-        </p:nvSpPr>
-        <p:spPr>
-          <a:xfrm>
-            <a:off x="5407756" y="1994693"/>
-            <a:ext cx="1371600" cy="914400"/>
-          </a:xfrm>
-          <a:prstGeom prst="rect">
-            <a:avLst/>
-          </a:prstGeom>
-          <a:solidFill>
-            <a:schemeClr val="accent6">
-              <a:lumMod val="20000"/>
-              <a:lumOff val="80000"/>
-            </a:schemeClr>
-          </a:solidFill>
-        </p:spPr>
-        <p:style>
-          <a:lnRef idx="2">
-            <a:schemeClr val="accent1">
-              <a:shade val="15000"/>
-            </a:schemeClr>
-          </a:lnRef>
-          <a:fillRef idx="1">
-            <a:schemeClr val="accent1"/>
-          </a:fillRef>
-          <a:effectRef idx="0">
-            <a:schemeClr val="accent1"/>
-          </a:effectRef>
-          <a:fontRef idx="minor">
-            <a:schemeClr val="lt1"/>
-          </a:fontRef>
-        </p:style>
-        <p:txBody>
-          <a:bodyPr rtlCol="0" anchor="ctr"/>
-          <a:lstStyle/>
-          <a:p>
-            <a:pPr algn="ctr"/>
-            <a:r>
-              <a:rPr lang="en-US" sz="1600" dirty="0">
-                <a:solidFill>
-                  <a:schemeClr val="tx1"/>
-                </a:solidFill>
-              </a:rPr>
-              <a:t>Desired Encoding Process</a:t>
-            </a:r>
-          </a:p>
-        </p:txBody>
-      </p:sp>
-      <p:sp>
-        <p:nvSpPr>
-          <p:cNvPr id="15" name="Rectangle 14">
-            <a:extLst>
-              <a:ext uri="{FF2B5EF4-FFF2-40B4-BE49-F238E27FC236}">
-                <a16:creationId xmlns:a16="http://schemas.microsoft.com/office/drawing/2014/main" id="{7BAD6213-7458-23E9-950D-48F51C7B7A28}"/>
-              </a:ext>
-            </a:extLst>
-          </p:cNvPr>
-          <p:cNvSpPr/>
-          <p:nvPr/>
-        </p:nvSpPr>
-        <p:spPr>
-          <a:xfrm>
-            <a:off x="7078367" y="1994693"/>
-            <a:ext cx="1371600" cy="914400"/>
-          </a:xfrm>
-          <a:prstGeom prst="rect">
-            <a:avLst/>
-          </a:prstGeom>
-          <a:solidFill>
-            <a:schemeClr val="accent6">
-              <a:lumMod val="20000"/>
-              <a:lumOff val="80000"/>
-            </a:schemeClr>
-          </a:solidFill>
-        </p:spPr>
-        <p:style>
-          <a:lnRef idx="2">
-            <a:schemeClr val="accent1">
-              <a:shade val="15000"/>
-            </a:schemeClr>
-          </a:lnRef>
-          <a:fillRef idx="1">
-            <a:schemeClr val="accent1"/>
-          </a:fillRef>
-          <a:effectRef idx="0">
-            <a:schemeClr val="accent1"/>
-          </a:effectRef>
-          <a:fontRef idx="minor">
-            <a:schemeClr val="lt1"/>
-          </a:fontRef>
-        </p:style>
-        <p:txBody>
-          <a:bodyPr rtlCol="0" anchor="ctr"/>
-          <a:lstStyle/>
-          <a:p>
-            <a:pPr algn="ctr"/>
-            <a:r>
-              <a:rPr lang="en-US" sz="1600" dirty="0">
-                <a:solidFill>
-                  <a:schemeClr val="tx1"/>
-                </a:solidFill>
-              </a:rPr>
-              <a:t>Data Shuffling and Randomizing</a:t>
-            </a:r>
-          </a:p>
-        </p:txBody>
-      </p:sp>
-      <p:sp>
-        <p:nvSpPr>
-          <p:cNvPr id="17" name="Rectangle 16">
-            <a:extLst>
-              <a:ext uri="{FF2B5EF4-FFF2-40B4-BE49-F238E27FC236}">
-                <a16:creationId xmlns:a16="http://schemas.microsoft.com/office/drawing/2014/main" id="{6A2A5672-27D9-B865-A117-5D10E060F642}"/>
-              </a:ext>
-            </a:extLst>
-          </p:cNvPr>
-          <p:cNvSpPr/>
-          <p:nvPr/>
-        </p:nvSpPr>
-        <p:spPr>
-          <a:xfrm>
-            <a:off x="8748979" y="1994693"/>
-            <a:ext cx="1371600" cy="914400"/>
-          </a:xfrm>
-          <a:prstGeom prst="rect">
-            <a:avLst/>
-          </a:prstGeom>
-          <a:solidFill>
-            <a:schemeClr val="accent6">
-              <a:lumMod val="20000"/>
-              <a:lumOff val="80000"/>
-            </a:schemeClr>
-          </a:solidFill>
-        </p:spPr>
-        <p:style>
-          <a:lnRef idx="2">
-            <a:schemeClr val="accent1">
-              <a:shade val="15000"/>
-            </a:schemeClr>
-          </a:lnRef>
-          <a:fillRef idx="1">
-            <a:schemeClr val="accent1"/>
-          </a:fillRef>
-          <a:effectRef idx="0">
-            <a:schemeClr val="accent1"/>
-          </a:effectRef>
-          <a:fontRef idx="minor">
-            <a:schemeClr val="lt1"/>
-          </a:fontRef>
-        </p:style>
-        <p:txBody>
-          <a:bodyPr rtlCol="0" anchor="ctr"/>
-          <a:lstStyle/>
-          <a:p>
-            <a:pPr algn="ctr"/>
-            <a:r>
-              <a:rPr lang="en-US" sz="1600" dirty="0">
-                <a:solidFill>
-                  <a:schemeClr val="tx1"/>
-                </a:solidFill>
-              </a:rPr>
-              <a:t>Data Framing</a:t>
-            </a:r>
-          </a:p>
-        </p:txBody>
-      </p:sp>
-      <p:sp>
-        <p:nvSpPr>
-          <p:cNvPr id="19" name="Rectangle 18">
-            <a:extLst>
-              <a:ext uri="{FF2B5EF4-FFF2-40B4-BE49-F238E27FC236}">
-                <a16:creationId xmlns:a16="http://schemas.microsoft.com/office/drawing/2014/main" id="{02B803AA-A284-FE71-EBFF-6BB7BCD79659}"/>
-              </a:ext>
-            </a:extLst>
-          </p:cNvPr>
-          <p:cNvSpPr/>
-          <p:nvPr/>
-        </p:nvSpPr>
-        <p:spPr>
-          <a:xfrm>
-            <a:off x="4244382" y="3519487"/>
-            <a:ext cx="3698348" cy="338932"/>
-          </a:xfrm>
-          <a:prstGeom prst="rect">
-            <a:avLst/>
-          </a:prstGeom>
-          <a:solidFill>
-            <a:schemeClr val="accent1">
-              <a:lumMod val="20000"/>
-              <a:lumOff val="80000"/>
-            </a:schemeClr>
-          </a:solidFill>
-        </p:spPr>
-        <p:style>
-          <a:lnRef idx="2">
-            <a:schemeClr val="accent1">
-              <a:shade val="15000"/>
-            </a:schemeClr>
-          </a:lnRef>
-          <a:fillRef idx="1">
-            <a:schemeClr val="accent1"/>
-          </a:fillRef>
-          <a:effectRef idx="0">
-            <a:schemeClr val="accent1"/>
-          </a:effectRef>
-          <a:fontRef idx="minor">
-            <a:schemeClr val="lt1"/>
-          </a:fontRef>
-        </p:style>
-        <p:txBody>
-          <a:bodyPr rtlCol="0" anchor="ctr"/>
-          <a:lstStyle/>
-          <a:p>
-            <a:pPr algn="ctr"/>
-            <a:r>
-              <a:rPr lang="en-US" sz="1600" dirty="0">
-                <a:solidFill>
-                  <a:schemeClr val="tx1"/>
-                </a:solidFill>
-              </a:rPr>
-              <a:t>Telemetry Board + Antenna</a:t>
-            </a:r>
-          </a:p>
-        </p:txBody>
-      </p:sp>
-      <p:cxnSp>
-        <p:nvCxnSpPr>
-          <p:cNvPr id="23" name="Straight Arrow Connector 22">
-            <a:extLst>
-              <a:ext uri="{FF2B5EF4-FFF2-40B4-BE49-F238E27FC236}">
-                <a16:creationId xmlns:a16="http://schemas.microsoft.com/office/drawing/2014/main" id="{6381EBEA-8992-2776-92EC-40D6727E48C2}"/>
-              </a:ext>
-            </a:extLst>
-          </p:cNvPr>
-          <p:cNvCxnSpPr>
-            <a:stCxn id="7" idx="3"/>
-            <a:endCxn id="9" idx="1"/>
-          </p:cNvCxnSpPr>
-          <p:nvPr/>
-        </p:nvCxnSpPr>
-        <p:spPr>
-          <a:xfrm>
-            <a:off x="3443021" y="2451893"/>
-            <a:ext cx="294123" cy="0"/>
-          </a:xfrm>
-          <a:prstGeom prst="straightConnector1">
-            <a:avLst/>
-          </a:prstGeom>
-          <a:ln>
-            <a:tailEnd type="triangle"/>
-          </a:ln>
-        </p:spPr>
-        <p:style>
-          <a:lnRef idx="2">
-            <a:schemeClr val="dk1"/>
-          </a:lnRef>
-          <a:fillRef idx="0">
-            <a:schemeClr val="dk1"/>
-          </a:fillRef>
-          <a:effectRef idx="1">
-            <a:schemeClr val="dk1"/>
-          </a:effectRef>
-          <a:fontRef idx="minor">
-            <a:schemeClr val="tx1"/>
-          </a:fontRef>
-        </p:style>
-      </p:cxnSp>
-      <p:cxnSp>
-        <p:nvCxnSpPr>
-          <p:cNvPr id="29" name="Straight Arrow Connector 28">
-            <a:extLst>
-              <a:ext uri="{FF2B5EF4-FFF2-40B4-BE49-F238E27FC236}">
-                <a16:creationId xmlns:a16="http://schemas.microsoft.com/office/drawing/2014/main" id="{4557113B-7ACF-E4BC-0A6E-8D6920C0CDD7}"/>
-              </a:ext>
-            </a:extLst>
-          </p:cNvPr>
-          <p:cNvCxnSpPr>
-            <a:stCxn id="9" idx="3"/>
-            <a:endCxn id="13" idx="1"/>
-          </p:cNvCxnSpPr>
-          <p:nvPr/>
-        </p:nvCxnSpPr>
-        <p:spPr>
-          <a:xfrm>
-            <a:off x="5108744" y="2451893"/>
-            <a:ext cx="299012" cy="0"/>
-          </a:xfrm>
-          <a:prstGeom prst="straightConnector1">
-            <a:avLst/>
-          </a:prstGeom>
-          <a:ln>
-            <a:tailEnd type="triangle"/>
-          </a:ln>
-        </p:spPr>
-        <p:style>
-          <a:lnRef idx="2">
-            <a:schemeClr val="dk1"/>
-          </a:lnRef>
-          <a:fillRef idx="0">
-            <a:schemeClr val="dk1"/>
-          </a:fillRef>
-          <a:effectRef idx="1">
-            <a:schemeClr val="dk1"/>
-          </a:effectRef>
-          <a:fontRef idx="minor">
-            <a:schemeClr val="tx1"/>
-          </a:fontRef>
-        </p:style>
-      </p:cxnSp>
-      <p:cxnSp>
-        <p:nvCxnSpPr>
-          <p:cNvPr id="31" name="Straight Arrow Connector 30">
-            <a:extLst>
-              <a:ext uri="{FF2B5EF4-FFF2-40B4-BE49-F238E27FC236}">
-                <a16:creationId xmlns:a16="http://schemas.microsoft.com/office/drawing/2014/main" id="{388A05CD-BC2F-F971-CAD0-77E0B2A15C4B}"/>
-              </a:ext>
-            </a:extLst>
-          </p:cNvPr>
-          <p:cNvCxnSpPr>
-            <a:stCxn id="13" idx="3"/>
-            <a:endCxn id="15" idx="1"/>
-          </p:cNvCxnSpPr>
-          <p:nvPr/>
-        </p:nvCxnSpPr>
-        <p:spPr>
-          <a:xfrm>
-            <a:off x="6779356" y="2451893"/>
-            <a:ext cx="299011" cy="0"/>
-          </a:xfrm>
-          <a:prstGeom prst="straightConnector1">
-            <a:avLst/>
-          </a:prstGeom>
-          <a:ln>
-            <a:tailEnd type="triangle"/>
-          </a:ln>
-        </p:spPr>
-        <p:style>
-          <a:lnRef idx="2">
-            <a:schemeClr val="dk1"/>
-          </a:lnRef>
-          <a:fillRef idx="0">
-            <a:schemeClr val="dk1"/>
-          </a:fillRef>
-          <a:effectRef idx="1">
-            <a:schemeClr val="dk1"/>
-          </a:effectRef>
-          <a:fontRef idx="minor">
-            <a:schemeClr val="tx1"/>
-          </a:fontRef>
-        </p:style>
-      </p:cxnSp>
-      <p:cxnSp>
-        <p:nvCxnSpPr>
-          <p:cNvPr id="33" name="Straight Arrow Connector 32">
-            <a:extLst>
-              <a:ext uri="{FF2B5EF4-FFF2-40B4-BE49-F238E27FC236}">
-                <a16:creationId xmlns:a16="http://schemas.microsoft.com/office/drawing/2014/main" id="{1CF511F9-2C63-5EA1-AC66-BB48C7A3E916}"/>
-              </a:ext>
-            </a:extLst>
-          </p:cNvPr>
-          <p:cNvCxnSpPr>
-            <a:stCxn id="15" idx="3"/>
-            <a:endCxn id="17" idx="1"/>
-          </p:cNvCxnSpPr>
-          <p:nvPr/>
-        </p:nvCxnSpPr>
-        <p:spPr>
-          <a:xfrm>
-            <a:off x="8449967" y="2451893"/>
-            <a:ext cx="299012" cy="0"/>
-          </a:xfrm>
-          <a:prstGeom prst="straightConnector1">
-            <a:avLst/>
-          </a:prstGeom>
-          <a:ln>
-            <a:tailEnd type="triangle"/>
-          </a:ln>
-        </p:spPr>
-        <p:style>
-          <a:lnRef idx="2">
-            <a:schemeClr val="dk1"/>
-          </a:lnRef>
-          <a:fillRef idx="0">
-            <a:schemeClr val="dk1"/>
-          </a:fillRef>
-          <a:effectRef idx="1">
-            <a:schemeClr val="dk1"/>
-          </a:effectRef>
-          <a:fontRef idx="minor">
-            <a:schemeClr val="tx1"/>
-          </a:fontRef>
-        </p:style>
-      </p:cxnSp>
-      <p:cxnSp>
-        <p:nvCxnSpPr>
-          <p:cNvPr id="35" name="Straight Arrow Connector 34">
-            <a:extLst>
-              <a:ext uri="{FF2B5EF4-FFF2-40B4-BE49-F238E27FC236}">
-                <a16:creationId xmlns:a16="http://schemas.microsoft.com/office/drawing/2014/main" id="{692486A0-D5CD-1E2B-0ED7-6012A0A945A6}"/>
-              </a:ext>
-            </a:extLst>
-          </p:cNvPr>
-          <p:cNvCxnSpPr>
-            <a:stCxn id="17" idx="2"/>
-            <a:endCxn id="19" idx="0"/>
-          </p:cNvCxnSpPr>
-          <p:nvPr/>
-        </p:nvCxnSpPr>
-        <p:spPr>
-          <a:xfrm rot="5400000">
-            <a:off x="7458971" y="1543679"/>
-            <a:ext cx="610394" cy="3341223"/>
-          </a:xfrm>
-          <a:prstGeom prst="bentConnector3">
-            <a:avLst>
-              <a:gd name="adj1" fmla="val 50000"/>
-            </a:avLst>
-          </a:prstGeom>
-          <a:ln>
-            <a:tailEnd type="triangle"/>
-          </a:ln>
-        </p:spPr>
-        <p:style>
-          <a:lnRef idx="2">
-            <a:schemeClr val="dk1"/>
-          </a:lnRef>
-          <a:fillRef idx="0">
-            <a:schemeClr val="dk1"/>
-          </a:fillRef>
-          <a:effectRef idx="1">
-            <a:schemeClr val="dk1"/>
-          </a:effectRef>
-          <a:fontRef idx="minor">
-            <a:schemeClr val="tx1"/>
-          </a:fontRef>
-        </p:style>
-      </p:cxnSp>
-      <p:sp>
-        <p:nvSpPr>
-          <p:cNvPr id="46" name="Rectangle 45">
-            <a:extLst>
-              <a:ext uri="{FF2B5EF4-FFF2-40B4-BE49-F238E27FC236}">
-                <a16:creationId xmlns:a16="http://schemas.microsoft.com/office/drawing/2014/main" id="{F08185FD-D771-EB8F-0C20-1898978FE003}"/>
-              </a:ext>
-            </a:extLst>
-          </p:cNvPr>
-          <p:cNvSpPr/>
-          <p:nvPr/>
-        </p:nvSpPr>
-        <p:spPr>
-          <a:xfrm>
-            <a:off x="4244381" y="4860528"/>
-            <a:ext cx="3698348" cy="338932"/>
-          </a:xfrm>
-          <a:prstGeom prst="rect">
-            <a:avLst/>
-          </a:prstGeom>
-          <a:solidFill>
-            <a:schemeClr val="accent1">
-              <a:lumMod val="20000"/>
-              <a:lumOff val="80000"/>
-            </a:schemeClr>
-          </a:solidFill>
-        </p:spPr>
-        <p:style>
-          <a:lnRef idx="2">
-            <a:schemeClr val="accent1">
-              <a:shade val="15000"/>
-            </a:schemeClr>
-          </a:lnRef>
-          <a:fillRef idx="1">
-            <a:schemeClr val="accent1"/>
-          </a:fillRef>
-          <a:effectRef idx="0">
-            <a:schemeClr val="accent1"/>
-          </a:effectRef>
-          <a:fontRef idx="minor">
-            <a:schemeClr val="lt1"/>
-          </a:fontRef>
-        </p:style>
-        <p:txBody>
-          <a:bodyPr rtlCol="0" anchor="ctr"/>
-          <a:lstStyle/>
-          <a:p>
-            <a:pPr algn="ctr"/>
-            <a:r>
-              <a:rPr lang="en-US" sz="1600" dirty="0">
-                <a:solidFill>
-                  <a:schemeClr val="tx1"/>
-                </a:solidFill>
-              </a:rPr>
-              <a:t>Telemetry Board + Antenna</a:t>
-            </a:r>
-          </a:p>
-        </p:txBody>
-      </p:sp>
-      <p:cxnSp>
-        <p:nvCxnSpPr>
-          <p:cNvPr id="48" name="Straight Arrow Connector 47">
-            <a:extLst>
-              <a:ext uri="{FF2B5EF4-FFF2-40B4-BE49-F238E27FC236}">
-                <a16:creationId xmlns:a16="http://schemas.microsoft.com/office/drawing/2014/main" id="{A0195D1C-52DE-6768-E1FE-425665537C8B}"/>
-              </a:ext>
-            </a:extLst>
-          </p:cNvPr>
-          <p:cNvCxnSpPr>
-            <a:cxnSpLocks/>
-            <a:stCxn id="21" idx="2"/>
-            <a:endCxn id="46" idx="0"/>
-          </p:cNvCxnSpPr>
-          <p:nvPr/>
-        </p:nvCxnSpPr>
-        <p:spPr>
-          <a:xfrm flipH="1">
-            <a:off x="6093555" y="3957638"/>
-            <a:ext cx="1" cy="902890"/>
-          </a:xfrm>
-          <a:prstGeom prst="straightConnector1">
-            <a:avLst/>
-          </a:prstGeom>
-          <a:ln>
-            <a:tailEnd type="triangle"/>
-          </a:ln>
-        </p:spPr>
-        <p:style>
-          <a:lnRef idx="2">
-            <a:schemeClr val="dk1"/>
-          </a:lnRef>
-          <a:fillRef idx="0">
-            <a:schemeClr val="dk1"/>
-          </a:fillRef>
-          <a:effectRef idx="1">
-            <a:schemeClr val="dk1"/>
-          </a:effectRef>
-          <a:fontRef idx="minor">
-            <a:schemeClr val="tx1"/>
-          </a:fontRef>
-        </p:style>
-      </p:cxnSp>
-    </p:spTree>
-    <p:extLst>
-      <p:ext uri="{BB962C8B-B14F-4D97-AF65-F5344CB8AC3E}">
-        <p14:creationId xmlns:p14="http://schemas.microsoft.com/office/powerpoint/2010/main" val="2689763080"/>
-      </p:ext>
-    </p:extLst>
-  </p:cSld>
-  <p:clrMapOvr>
-    <a:masterClrMapping/>
-  </p:clrMapOvr>
-</p:sld>
-</file>
-
-<file path=ppt/slides/slide2.xml><?xml version="1.0" encoding="utf-8"?>
-<p:sld xmlns:a="http://schemas.openxmlformats.org/drawingml/2006/main" xmlns:r="http://schemas.openxmlformats.org/officeDocument/2006/relationships" xmlns:p="http://schemas.openxmlformats.org/presentationml/2006/main">
-  <p:cSld>
-    <p:spTree>
-      <p:nvGrpSpPr>
         <p:cNvPr id="1" name="">
           <a:extLst>
             <a:ext uri="{FF2B5EF4-FFF2-40B4-BE49-F238E27FC236}">
@@ -6120,6 +5393,653 @@
     <p:extLst>
       <p:ext uri="{BB962C8B-B14F-4D97-AF65-F5344CB8AC3E}">
         <p14:creationId xmlns:p14="http://schemas.microsoft.com/office/powerpoint/2010/main" val="3408834207"/>
+      </p:ext>
+    </p:extLst>
+  </p:cSld>
+  <p:clrMapOvr>
+    <a:masterClrMapping/>
+  </p:clrMapOvr>
+</p:sld>
+</file>
+
+<file path=ppt/slides/slide2.xml><?xml version="1.0" encoding="utf-8"?>
+<p:sld xmlns:a="http://schemas.openxmlformats.org/drawingml/2006/main" xmlns:r="http://schemas.openxmlformats.org/officeDocument/2006/relationships" xmlns:p="http://schemas.openxmlformats.org/presentationml/2006/main">
+  <p:cSld>
+    <p:spTree>
+      <p:nvGrpSpPr>
+        <p:cNvPr id="1" name="">
+          <a:extLst>
+            <a:ext uri="{FF2B5EF4-FFF2-40B4-BE49-F238E27FC236}">
+              <a16:creationId xmlns:a16="http://schemas.microsoft.com/office/drawing/2014/main" id="{62C7A003-BA4E-9775-B032-52064AFAA4E9}"/>
+            </a:ext>
+          </a:extLst>
+        </p:cNvPr>
+        <p:cNvGrpSpPr/>
+        <p:nvPr/>
+      </p:nvGrpSpPr>
+      <p:grpSpPr>
+        <a:xfrm>
+          <a:off x="0" y="0"/>
+          <a:ext cx="0" cy="0"/>
+          <a:chOff x="0" y="0"/>
+          <a:chExt cx="0" cy="0"/>
+        </a:xfrm>
+      </p:grpSpPr>
+      <p:graphicFrame>
+        <p:nvGraphicFramePr>
+          <p:cNvPr id="12" name="Table 11">
+            <a:extLst>
+              <a:ext uri="{FF2B5EF4-FFF2-40B4-BE49-F238E27FC236}">
+                <a16:creationId xmlns:a16="http://schemas.microsoft.com/office/drawing/2014/main" id="{D50B234F-5A5B-2CB2-DA3C-6B67A60AE135}"/>
+              </a:ext>
+            </a:extLst>
+          </p:cNvPr>
+          <p:cNvGraphicFramePr>
+            <a:graphicFrameLocks noGrp="1"/>
+          </p:cNvGraphicFramePr>
+          <p:nvPr>
+            <p:extLst>
+              <p:ext uri="{D42A27DB-BD31-4B8C-83A1-F6EECF244321}">
+                <p14:modId xmlns:p14="http://schemas.microsoft.com/office/powerpoint/2010/main" val="2076080180"/>
+              </p:ext>
+            </p:extLst>
+          </p:nvPr>
+        </p:nvGraphicFramePr>
+        <p:xfrm>
+          <a:off x="3925887" y="1389380"/>
+          <a:ext cx="4340225" cy="4079240"/>
+        </p:xfrm>
+        <a:graphic>
+          <a:graphicData uri="http://schemas.openxmlformats.org/drawingml/2006/table">
+            <a:tbl>
+              <a:tblPr firstRow="1" bandRow="1">
+                <a:tableStyleId>{5C22544A-7EE6-4342-B048-85BDC9FD1C3A}</a:tableStyleId>
+              </a:tblPr>
+              <a:tblGrid>
+                <a:gridCol w="3044039">
+                  <a:extLst>
+                    <a:ext uri="{9D8B030D-6E8A-4147-A177-3AD203B41FA5}">
+                      <a16:colId xmlns:a16="http://schemas.microsoft.com/office/drawing/2014/main" val="2412178877"/>
+                    </a:ext>
+                  </a:extLst>
+                </a:gridCol>
+                <a:gridCol w="1296186">
+                  <a:extLst>
+                    <a:ext uri="{9D8B030D-6E8A-4147-A177-3AD203B41FA5}">
+                      <a16:colId xmlns:a16="http://schemas.microsoft.com/office/drawing/2014/main" val="1688104225"/>
+                    </a:ext>
+                  </a:extLst>
+                </a:gridCol>
+              </a:tblGrid>
+              <a:tr h="370840">
+                <a:tc>
+                  <a:txBody>
+                    <a:bodyPr/>
+                    <a:lstStyle/>
+                    <a:p>
+                      <a:pPr algn="ctr" fontAlgn="ctr">
+                        <a:buNone/>
+                      </a:pPr>
+                      <a:r>
+                        <a:rPr lang="en-US" sz="1800" b="0" i="0" u="none" strike="noStrike" dirty="0">
+                          <a:solidFill>
+                            <a:schemeClr val="bg1"/>
+                          </a:solidFill>
+                          <a:effectLst/>
+                          <a:latin typeface="+mn-lt"/>
+                        </a:rPr>
+                        <a:t>Value</a:t>
+                      </a:r>
+                    </a:p>
+                  </a:txBody>
+                  <a:tcPr marL="4763" marR="4763" marT="4763" marB="0" anchor="ctr"/>
+                </a:tc>
+                <a:tc>
+                  <a:txBody>
+                    <a:bodyPr/>
+                    <a:lstStyle/>
+                    <a:p>
+                      <a:pPr algn="ctr" fontAlgn="ctr">
+                        <a:buNone/>
+                      </a:pPr>
+                      <a:r>
+                        <a:rPr lang="en-US" sz="1800" b="0" i="0" u="none" strike="noStrike" dirty="0">
+                          <a:solidFill>
+                            <a:schemeClr val="bg1"/>
+                          </a:solidFill>
+                          <a:effectLst/>
+                          <a:latin typeface="+mn-lt"/>
+                        </a:rPr>
+                        <a:t>Size (bytes)</a:t>
+                      </a:r>
+                    </a:p>
+                  </a:txBody>
+                  <a:tcPr marL="4763" marR="4763" marT="4763" marB="0" anchor="ctr"/>
+                </a:tc>
+                <a:extLst>
+                  <a:ext uri="{0D108BD9-81ED-4DB2-BD59-A6C34878D82A}">
+                    <a16:rowId xmlns:a16="http://schemas.microsoft.com/office/drawing/2014/main" val="3542141459"/>
+                  </a:ext>
+                </a:extLst>
+              </a:tr>
+              <a:tr h="370840">
+                <a:tc>
+                  <a:txBody>
+                    <a:bodyPr/>
+                    <a:lstStyle/>
+                    <a:p>
+                      <a:pPr algn="ctr" fontAlgn="ctr">
+                        <a:buNone/>
+                      </a:pPr>
+                      <a:r>
+                        <a:rPr lang="en-US" sz="1800" b="0" i="0" u="none" strike="noStrike" dirty="0">
+                          <a:solidFill>
+                            <a:srgbClr val="000000"/>
+                          </a:solidFill>
+                          <a:effectLst/>
+                          <a:latin typeface="+mn-lt"/>
+                        </a:rPr>
+                        <a:t>Frame Count</a:t>
+                      </a:r>
+                    </a:p>
+                  </a:txBody>
+                  <a:tcPr marL="4763" marR="4763" marT="4763" marB="0" anchor="ctr"/>
+                </a:tc>
+                <a:tc>
+                  <a:txBody>
+                    <a:bodyPr/>
+                    <a:lstStyle/>
+                    <a:p>
+                      <a:pPr algn="r" fontAlgn="ctr">
+                        <a:buNone/>
+                      </a:pPr>
+                      <a:r>
+                        <a:rPr lang="en-US" sz="1800" b="0" i="0" u="none" strike="noStrike" dirty="0">
+                          <a:solidFill>
+                            <a:srgbClr val="000000"/>
+                          </a:solidFill>
+                          <a:effectLst/>
+                          <a:latin typeface="+mn-lt"/>
+                        </a:rPr>
+                        <a:t>2</a:t>
+                      </a:r>
+                    </a:p>
+                  </a:txBody>
+                  <a:tcPr marL="4763" marR="4763" marT="4763" marB="0" anchor="ctr"/>
+                </a:tc>
+                <a:extLst>
+                  <a:ext uri="{0D108BD9-81ED-4DB2-BD59-A6C34878D82A}">
+                    <a16:rowId xmlns:a16="http://schemas.microsoft.com/office/drawing/2014/main" val="922446469"/>
+                  </a:ext>
+                </a:extLst>
+              </a:tr>
+              <a:tr h="370840">
+                <a:tc>
+                  <a:txBody>
+                    <a:bodyPr/>
+                    <a:lstStyle/>
+                    <a:p>
+                      <a:pPr algn="ctr" fontAlgn="ctr">
+                        <a:buNone/>
+                      </a:pPr>
+                      <a:r>
+                        <a:rPr lang="en-US" sz="1800" b="0" i="0" u="none" strike="noStrike">
+                          <a:solidFill>
+                            <a:srgbClr val="000000"/>
+                          </a:solidFill>
+                          <a:effectLst/>
+                          <a:latin typeface="+mn-lt"/>
+                        </a:rPr>
+                        <a:t>Timestamp</a:t>
+                      </a:r>
+                    </a:p>
+                  </a:txBody>
+                  <a:tcPr marL="4763" marR="4763" marT="4763" marB="0" anchor="ctr"/>
+                </a:tc>
+                <a:tc>
+                  <a:txBody>
+                    <a:bodyPr/>
+                    <a:lstStyle/>
+                    <a:p>
+                      <a:pPr algn="r" fontAlgn="ctr">
+                        <a:buNone/>
+                      </a:pPr>
+                      <a:r>
+                        <a:rPr lang="en-US" sz="1800" b="0" i="0" u="none" strike="noStrike" dirty="0">
+                          <a:solidFill>
+                            <a:srgbClr val="000000"/>
+                          </a:solidFill>
+                          <a:effectLst/>
+                          <a:latin typeface="+mn-lt"/>
+                        </a:rPr>
+                        <a:t>4</a:t>
+                      </a:r>
+                    </a:p>
+                  </a:txBody>
+                  <a:tcPr marL="4763" marR="4763" marT="4763" marB="0" anchor="ctr"/>
+                </a:tc>
+                <a:extLst>
+                  <a:ext uri="{0D108BD9-81ED-4DB2-BD59-A6C34878D82A}">
+                    <a16:rowId xmlns:a16="http://schemas.microsoft.com/office/drawing/2014/main" val="2617919086"/>
+                  </a:ext>
+                </a:extLst>
+              </a:tr>
+              <a:tr h="370840">
+                <a:tc>
+                  <a:txBody>
+                    <a:bodyPr/>
+                    <a:lstStyle/>
+                    <a:p>
+                      <a:pPr algn="ctr" fontAlgn="ctr">
+                        <a:buNone/>
+                      </a:pPr>
+                      <a:r>
+                        <a:rPr lang="en-US" sz="1800" b="0" i="0" u="none" strike="noStrike">
+                          <a:solidFill>
+                            <a:srgbClr val="000000"/>
+                          </a:solidFill>
+                          <a:effectLst/>
+                          <a:latin typeface="+mn-lt"/>
+                        </a:rPr>
+                        <a:t>Antenna ID (?)</a:t>
+                      </a:r>
+                    </a:p>
+                  </a:txBody>
+                  <a:tcPr marL="4763" marR="4763" marT="4763" marB="0" anchor="ctr"/>
+                </a:tc>
+                <a:tc>
+                  <a:txBody>
+                    <a:bodyPr/>
+                    <a:lstStyle/>
+                    <a:p>
+                      <a:pPr algn="r" fontAlgn="ctr">
+                        <a:buNone/>
+                      </a:pPr>
+                      <a:r>
+                        <a:rPr lang="en-US" sz="1800" b="0" i="0" u="none" strike="noStrike" dirty="0">
+                          <a:solidFill>
+                            <a:srgbClr val="000000"/>
+                          </a:solidFill>
+                          <a:effectLst/>
+                          <a:latin typeface="+mn-lt"/>
+                        </a:rPr>
+                        <a:t>1</a:t>
+                      </a:r>
+                    </a:p>
+                  </a:txBody>
+                  <a:tcPr marL="4763" marR="4763" marT="4763" marB="0" anchor="ctr"/>
+                </a:tc>
+                <a:extLst>
+                  <a:ext uri="{0D108BD9-81ED-4DB2-BD59-A6C34878D82A}">
+                    <a16:rowId xmlns:a16="http://schemas.microsoft.com/office/drawing/2014/main" val="3813193492"/>
+                  </a:ext>
+                </a:extLst>
+              </a:tr>
+              <a:tr h="370840">
+                <a:tc>
+                  <a:txBody>
+                    <a:bodyPr/>
+                    <a:lstStyle/>
+                    <a:p>
+                      <a:pPr algn="ctr" fontAlgn="ctr">
+                        <a:buNone/>
+                      </a:pPr>
+                      <a:r>
+                        <a:rPr lang="en-US" sz="1800" b="0" i="0" u="none" strike="noStrike" dirty="0">
+                          <a:solidFill>
+                            <a:srgbClr val="000000"/>
+                          </a:solidFill>
+                          <a:effectLst/>
+                          <a:latin typeface="+mn-lt"/>
+                        </a:rPr>
+                        <a:t>CRC Length</a:t>
+                      </a:r>
+                    </a:p>
+                  </a:txBody>
+                  <a:tcPr marL="4763" marR="4763" marT="4763" marB="0" anchor="ctr"/>
+                </a:tc>
+                <a:tc>
+                  <a:txBody>
+                    <a:bodyPr/>
+                    <a:lstStyle/>
+                    <a:p>
+                      <a:pPr algn="r" fontAlgn="ctr">
+                        <a:buNone/>
+                      </a:pPr>
+                      <a:r>
+                        <a:rPr lang="en-US" sz="1800" b="0" i="0" u="none" strike="noStrike">
+                          <a:solidFill>
+                            <a:srgbClr val="000000"/>
+                          </a:solidFill>
+                          <a:effectLst/>
+                          <a:latin typeface="+mn-lt"/>
+                        </a:rPr>
+                        <a:t>2</a:t>
+                      </a:r>
+                    </a:p>
+                  </a:txBody>
+                  <a:tcPr marL="4763" marR="4763" marT="4763" marB="0" anchor="ctr"/>
+                </a:tc>
+                <a:extLst>
+                  <a:ext uri="{0D108BD9-81ED-4DB2-BD59-A6C34878D82A}">
+                    <a16:rowId xmlns:a16="http://schemas.microsoft.com/office/drawing/2014/main" val="78094819"/>
+                  </a:ext>
+                </a:extLst>
+              </a:tr>
+              <a:tr h="370840">
+                <a:tc>
+                  <a:txBody>
+                    <a:bodyPr/>
+                    <a:lstStyle/>
+                    <a:p>
+                      <a:pPr algn="ctr" fontAlgn="ctr">
+                        <a:buNone/>
+                      </a:pPr>
+                      <a:r>
+                        <a:rPr lang="en-US" sz="1800" b="0" i="0" u="none" strike="noStrike">
+                          <a:solidFill>
+                            <a:srgbClr val="000000"/>
+                          </a:solidFill>
+                          <a:effectLst/>
+                          <a:latin typeface="+mn-lt"/>
+                        </a:rPr>
+                        <a:t>Sync Marker</a:t>
+                      </a:r>
+                    </a:p>
+                  </a:txBody>
+                  <a:tcPr marL="4763" marR="4763" marT="4763" marB="0" anchor="ctr"/>
+                </a:tc>
+                <a:tc>
+                  <a:txBody>
+                    <a:bodyPr/>
+                    <a:lstStyle/>
+                    <a:p>
+                      <a:pPr algn="r" fontAlgn="ctr">
+                        <a:buNone/>
+                      </a:pPr>
+                      <a:r>
+                        <a:rPr lang="en-US" sz="1800" b="0" i="0" u="none" strike="noStrike" dirty="0">
+                          <a:solidFill>
+                            <a:srgbClr val="000000"/>
+                          </a:solidFill>
+                          <a:effectLst/>
+                          <a:latin typeface="+mn-lt"/>
+                        </a:rPr>
+                        <a:t>4</a:t>
+                      </a:r>
+                    </a:p>
+                  </a:txBody>
+                  <a:tcPr marL="4763" marR="4763" marT="4763" marB="0" anchor="ctr"/>
+                </a:tc>
+                <a:extLst>
+                  <a:ext uri="{0D108BD9-81ED-4DB2-BD59-A6C34878D82A}">
+                    <a16:rowId xmlns:a16="http://schemas.microsoft.com/office/drawing/2014/main" val="2752540859"/>
+                  </a:ext>
+                </a:extLst>
+              </a:tr>
+              <a:tr h="370840">
+                <a:tc>
+                  <a:txBody>
+                    <a:bodyPr/>
+                    <a:lstStyle/>
+                    <a:p>
+                      <a:pPr algn="ctr" fontAlgn="ctr">
+                        <a:buNone/>
+                      </a:pPr>
+                      <a:r>
+                        <a:rPr lang="en-US" sz="1800" b="0" i="0" u="none" strike="noStrike">
+                          <a:solidFill>
+                            <a:srgbClr val="000000"/>
+                          </a:solidFill>
+                          <a:effectLst/>
+                          <a:latin typeface="+mn-lt"/>
+                        </a:rPr>
+                        <a:t>Parity per 4 Blocks of Data</a:t>
+                      </a:r>
+                    </a:p>
+                  </a:txBody>
+                  <a:tcPr marL="4763" marR="4763" marT="4763" marB="0" anchor="ctr"/>
+                </a:tc>
+                <a:tc>
+                  <a:txBody>
+                    <a:bodyPr/>
+                    <a:lstStyle/>
+                    <a:p>
+                      <a:pPr algn="r" fontAlgn="ctr">
+                        <a:buNone/>
+                      </a:pPr>
+                      <a:r>
+                        <a:rPr lang="en-US" sz="1800" b="0" i="0" u="none" strike="noStrike" dirty="0">
+                          <a:solidFill>
+                            <a:srgbClr val="000000"/>
+                          </a:solidFill>
+                          <a:effectLst/>
+                          <a:latin typeface="+mn-lt"/>
+                        </a:rPr>
+                        <a:t>128</a:t>
+                      </a:r>
+                    </a:p>
+                  </a:txBody>
+                  <a:tcPr marL="4763" marR="4763" marT="4763" marB="0" anchor="ctr"/>
+                </a:tc>
+                <a:extLst>
+                  <a:ext uri="{0D108BD9-81ED-4DB2-BD59-A6C34878D82A}">
+                    <a16:rowId xmlns:a16="http://schemas.microsoft.com/office/drawing/2014/main" val="1577733899"/>
+                  </a:ext>
+                </a:extLst>
+              </a:tr>
+              <a:tr h="370840">
+                <a:tc>
+                  <a:txBody>
+                    <a:bodyPr/>
+                    <a:lstStyle/>
+                    <a:p>
+                      <a:pPr algn="ctr" fontAlgn="ctr">
+                        <a:buNone/>
+                      </a:pPr>
+                      <a:r>
+                        <a:rPr lang="en-US" sz="1800" b="0" i="0" u="none" strike="noStrike" dirty="0">
+                          <a:solidFill>
+                            <a:srgbClr val="000000"/>
+                          </a:solidFill>
+                          <a:effectLst/>
+                          <a:latin typeface="+mn-lt"/>
+                        </a:rPr>
+                        <a:t>Data Length</a:t>
+                      </a:r>
+                    </a:p>
+                  </a:txBody>
+                  <a:tcPr marL="4763" marR="4763" marT="4763" marB="0" anchor="ctr"/>
+                </a:tc>
+                <a:tc>
+                  <a:txBody>
+                    <a:bodyPr/>
+                    <a:lstStyle/>
+                    <a:p>
+                      <a:pPr algn="r" fontAlgn="ctr">
+                        <a:buNone/>
+                      </a:pPr>
+                      <a:r>
+                        <a:rPr lang="en-US" sz="1800" b="0" i="0" u="none" strike="noStrike" dirty="0">
+                          <a:solidFill>
+                            <a:srgbClr val="000000"/>
+                          </a:solidFill>
+                          <a:effectLst/>
+                          <a:latin typeface="+mn-lt"/>
+                        </a:rPr>
+                        <a:t>2</a:t>
+                      </a:r>
+                    </a:p>
+                  </a:txBody>
+                  <a:tcPr marL="4763" marR="4763" marT="4763" marB="0" anchor="ctr"/>
+                </a:tc>
+                <a:extLst>
+                  <a:ext uri="{0D108BD9-81ED-4DB2-BD59-A6C34878D82A}">
+                    <a16:rowId xmlns:a16="http://schemas.microsoft.com/office/drawing/2014/main" val="2301061399"/>
+                  </a:ext>
+                </a:extLst>
+              </a:tr>
+              <a:tr h="370840">
+                <a:tc>
+                  <a:txBody>
+                    <a:bodyPr/>
+                    <a:lstStyle/>
+                    <a:p>
+                      <a:pPr algn="ctr" fontAlgn="ctr">
+                        <a:buNone/>
+                      </a:pPr>
+                      <a:r>
+                        <a:rPr lang="en-US" sz="1800" b="0" i="0" u="none" strike="noStrike">
+                          <a:solidFill>
+                            <a:srgbClr val="000000"/>
+                          </a:solidFill>
+                          <a:effectLst/>
+                          <a:latin typeface="+mn-lt"/>
+                        </a:rPr>
+                        <a:t>Frame Type</a:t>
+                      </a:r>
+                    </a:p>
+                  </a:txBody>
+                  <a:tcPr marL="4763" marR="4763" marT="4763" marB="0" anchor="ctr"/>
+                </a:tc>
+                <a:tc>
+                  <a:txBody>
+                    <a:bodyPr/>
+                    <a:lstStyle/>
+                    <a:p>
+                      <a:pPr algn="r" fontAlgn="ctr">
+                        <a:buNone/>
+                      </a:pPr>
+                      <a:r>
+                        <a:rPr lang="en-US" sz="1800" b="0" i="0" u="none" strike="noStrike" dirty="0">
+                          <a:solidFill>
+                            <a:srgbClr val="000000"/>
+                          </a:solidFill>
+                          <a:effectLst/>
+                          <a:latin typeface="+mn-lt"/>
+                        </a:rPr>
+                        <a:t>1</a:t>
+                      </a:r>
+                    </a:p>
+                  </a:txBody>
+                  <a:tcPr marL="4763" marR="4763" marT="4763" marB="0" anchor="ctr"/>
+                </a:tc>
+                <a:extLst>
+                  <a:ext uri="{0D108BD9-81ED-4DB2-BD59-A6C34878D82A}">
+                    <a16:rowId xmlns:a16="http://schemas.microsoft.com/office/drawing/2014/main" val="588886743"/>
+                  </a:ext>
+                </a:extLst>
+              </a:tr>
+              <a:tr h="370840">
+                <a:tc>
+                  <a:txBody>
+                    <a:bodyPr/>
+                    <a:lstStyle/>
+                    <a:p>
+                      <a:pPr algn="ctr" fontAlgn="ctr">
+                        <a:buNone/>
+                      </a:pPr>
+                      <a:r>
+                        <a:rPr lang="en-US" sz="1800" b="0" i="0" u="none" strike="noStrike" dirty="0">
+                          <a:solidFill>
+                            <a:srgbClr val="000000"/>
+                          </a:solidFill>
+                          <a:effectLst/>
+                          <a:latin typeface="+mn-lt"/>
+                        </a:rPr>
+                        <a:t>Available Sensor Data Space</a:t>
+                      </a:r>
+                    </a:p>
+                  </a:txBody>
+                  <a:tcPr marL="4763" marR="4763" marT="4763" marB="0" anchor="ctr"/>
+                </a:tc>
+                <a:tc>
+                  <a:txBody>
+                    <a:bodyPr/>
+                    <a:lstStyle/>
+                    <a:p>
+                      <a:pPr algn="r" fontAlgn="ctr">
+                        <a:buNone/>
+                      </a:pPr>
+                      <a:r>
+                        <a:rPr lang="en-US" sz="1800" b="0" i="0" u="none" strike="noStrike" dirty="0">
+                          <a:solidFill>
+                            <a:srgbClr val="000000"/>
+                          </a:solidFill>
+                          <a:effectLst/>
+                          <a:latin typeface="+mn-lt"/>
+                        </a:rPr>
+                        <a:t>880</a:t>
+                      </a:r>
+                    </a:p>
+                  </a:txBody>
+                  <a:tcPr marL="4763" marR="4763" marT="4763" marB="0" anchor="ctr"/>
+                </a:tc>
+                <a:extLst>
+                  <a:ext uri="{0D108BD9-81ED-4DB2-BD59-A6C34878D82A}">
+                    <a16:rowId xmlns:a16="http://schemas.microsoft.com/office/drawing/2014/main" val="2470901433"/>
+                  </a:ext>
+                </a:extLst>
+              </a:tr>
+              <a:tr h="370840">
+                <a:tc>
+                  <a:txBody>
+                    <a:bodyPr/>
+                    <a:lstStyle/>
+                    <a:p>
+                      <a:pPr algn="ctr" fontAlgn="ctr">
+                        <a:buNone/>
+                      </a:pPr>
+                      <a:r>
+                        <a:rPr lang="en-US" sz="1800" b="0" i="0" u="none" strike="noStrike" dirty="0">
+                          <a:solidFill>
+                            <a:srgbClr val="000000"/>
+                          </a:solidFill>
+                          <a:effectLst/>
+                          <a:latin typeface="+mn-lt"/>
+                        </a:rPr>
+                        <a:t>Total Frame Size</a:t>
+                      </a:r>
+                    </a:p>
+                  </a:txBody>
+                  <a:tcPr marL="4763" marR="4763" marT="4763" marB="0" anchor="ctr"/>
+                </a:tc>
+                <a:tc>
+                  <a:txBody>
+                    <a:bodyPr/>
+                    <a:lstStyle/>
+                    <a:p>
+                      <a:pPr algn="r" fontAlgn="ctr">
+                        <a:buNone/>
+                      </a:pPr>
+                      <a:r>
+                        <a:rPr lang="en-US" sz="1800" b="0" i="0" u="none" strike="noStrike" dirty="0">
+                          <a:solidFill>
+                            <a:srgbClr val="000000"/>
+                          </a:solidFill>
+                          <a:effectLst/>
+                          <a:latin typeface="+mn-lt"/>
+                        </a:rPr>
+                        <a:t>1024</a:t>
+                      </a:r>
+                    </a:p>
+                  </a:txBody>
+                  <a:tcPr marL="4763" marR="4763" marT="4763" marB="0" anchor="ctr"/>
+                </a:tc>
+                <a:extLst>
+                  <a:ext uri="{0D108BD9-81ED-4DB2-BD59-A6C34878D82A}">
+                    <a16:rowId xmlns:a16="http://schemas.microsoft.com/office/drawing/2014/main" val="1659077646"/>
+                  </a:ext>
+                </a:extLst>
+              </a:tr>
+            </a:tbl>
+          </a:graphicData>
+        </a:graphic>
+      </p:graphicFrame>
+    </p:spTree>
+    <p:extLst>
+      <p:ext uri="{BB962C8B-B14F-4D97-AF65-F5344CB8AC3E}">
+        <p14:creationId xmlns:p14="http://schemas.microsoft.com/office/powerpoint/2010/main" val="3549183859"/>
       </p:ext>
     </p:extLst>
   </p:cSld>

</xml_diff>